<commit_message>
feat(presentation): restyle 7-slide enterprise deck into FinSight_AI_Pitch_Deck_Frontier without overwriting
</commit_message>
<xml_diff>
--- a/presentation/FinSight_AI_Pitch_Deck_Enterprise.pptx
+++ b/presentation/FinSight_AI_Pitch_Deck_Enterprise.pptx
@@ -3106,6 +3106,106 @@
       </p:grpSpPr>
       <p:sp>
         <p:nvSpPr>
+          <p:cNvPr id="15" name="Oval 3">
+            <a:extLst>
+              <a:ext uri="{FF2B5EF4-FFF2-40B4-BE49-F238E27FC236}">
+                <a16:creationId xmlns:a16="http://schemas.microsoft.com/office/drawing/2014/main" id="{D1F6FBB5-A2AE-DB58-C07B-4469EE231EAF}"/>
+              </a:ext>
+            </a:extLst>
+          </p:cNvPr>
+          <p:cNvSpPr/>
+          <p:nvPr/>
+        </p:nvSpPr>
+        <p:spPr>
+          <a:xfrm>
+            <a:off x="-1828800" y="4114800"/>
+            <a:ext cx="5029200" cy="4572000"/>
+          </a:xfrm>
+          <a:prstGeom prst="ellipse">
+            <a:avLst/>
+          </a:prstGeom>
+          <a:solidFill>
+            <a:srgbClr val="0A121E"/>
+          </a:solidFill>
+          <a:ln>
+            <a:noFill/>
+          </a:ln>
+        </p:spPr>
+        <p:style>
+          <a:lnRef idx="1">
+            <a:schemeClr val="accent1"/>
+          </a:lnRef>
+          <a:fillRef idx="3">
+            <a:schemeClr val="accent1"/>
+          </a:fillRef>
+          <a:effectRef idx="2">
+            <a:schemeClr val="accent1"/>
+          </a:effectRef>
+          <a:fontRef idx="minor">
+            <a:schemeClr val="lt1"/>
+          </a:fontRef>
+        </p:style>
+        <p:txBody>
+          <a:bodyPr rtlCol="0" anchor="ctr"/>
+          <a:lstStyle/>
+          <a:p>
+            <a:pPr algn="ctr"/>
+            <a:endParaRPr/>
+          </a:p>
+        </p:txBody>
+      </p:sp>
+      <p:sp>
+        <p:nvSpPr>
+          <p:cNvPr id="13" name="Oval 2">
+            <a:extLst>
+              <a:ext uri="{FF2B5EF4-FFF2-40B4-BE49-F238E27FC236}">
+                <a16:creationId xmlns:a16="http://schemas.microsoft.com/office/drawing/2014/main" id="{348A128A-76F3-235A-7F3B-90922DB548A3}"/>
+              </a:ext>
+            </a:extLst>
+          </p:cNvPr>
+          <p:cNvSpPr/>
+          <p:nvPr/>
+        </p:nvSpPr>
+        <p:spPr>
+          <a:xfrm>
+            <a:off x="8153400" y="-1879092"/>
+            <a:ext cx="5943600" cy="5486400"/>
+          </a:xfrm>
+          <a:prstGeom prst="ellipse">
+            <a:avLst/>
+          </a:prstGeom>
+          <a:solidFill>
+            <a:srgbClr val="0C1C30"/>
+          </a:solidFill>
+          <a:ln>
+            <a:noFill/>
+          </a:ln>
+        </p:spPr>
+        <p:style>
+          <a:lnRef idx="1">
+            <a:schemeClr val="accent1"/>
+          </a:lnRef>
+          <a:fillRef idx="3">
+            <a:schemeClr val="accent1"/>
+          </a:fillRef>
+          <a:effectRef idx="2">
+            <a:schemeClr val="accent1"/>
+          </a:effectRef>
+          <a:fontRef idx="minor">
+            <a:schemeClr val="lt1"/>
+          </a:fontRef>
+        </p:style>
+        <p:txBody>
+          <a:bodyPr rtlCol="0" anchor="ctr"/>
+          <a:lstStyle/>
+          <a:p>
+            <a:pPr algn="ctr"/>
+            <a:endParaRPr/>
+          </a:p>
+        </p:txBody>
+      </p:sp>
+      <p:sp>
+        <p:nvSpPr>
           <p:cNvPr id="2" name="TextBox 1"/>
           <p:cNvSpPr txBox="1"/>
           <p:nvPr/>
@@ -3524,6 +3624,108 @@
       </p:grpSpPr>
       <p:sp>
         <p:nvSpPr>
+          <p:cNvPr id="26" name="Oval 2">
+            <a:extLst>
+              <a:ext uri="{FF2B5EF4-FFF2-40B4-BE49-F238E27FC236}">
+                <a16:creationId xmlns:a16="http://schemas.microsoft.com/office/drawing/2014/main" id="{2E3941C2-3042-1671-0628-CAE4BC9E2863}"/>
+              </a:ext>
+            </a:extLst>
+          </p:cNvPr>
+          <p:cNvSpPr/>
+          <p:nvPr/>
+        </p:nvSpPr>
+        <p:spPr>
+          <a:xfrm>
+            <a:off x="7772400" y="-1371600"/>
+            <a:ext cx="5943600" cy="5486400"/>
+          </a:xfrm>
+          <a:prstGeom prst="ellipse">
+            <a:avLst/>
+          </a:prstGeom>
+          <a:solidFill>
+            <a:srgbClr val="6B3305">
+              <a:alpha val="69804"/>
+            </a:srgbClr>
+          </a:solidFill>
+          <a:ln>
+            <a:noFill/>
+          </a:ln>
+        </p:spPr>
+        <p:style>
+          <a:lnRef idx="1">
+            <a:schemeClr val="accent1"/>
+          </a:lnRef>
+          <a:fillRef idx="3">
+            <a:schemeClr val="accent1"/>
+          </a:fillRef>
+          <a:effectRef idx="2">
+            <a:schemeClr val="accent1"/>
+          </a:effectRef>
+          <a:fontRef idx="minor">
+            <a:schemeClr val="lt1"/>
+          </a:fontRef>
+        </p:style>
+        <p:txBody>
+          <a:bodyPr rtlCol="0" anchor="ctr"/>
+          <a:lstStyle/>
+          <a:p>
+            <a:pPr algn="ctr"/>
+            <a:endParaRPr dirty="0"/>
+          </a:p>
+        </p:txBody>
+      </p:sp>
+      <p:sp>
+        <p:nvSpPr>
+          <p:cNvPr id="28" name="Oval 3">
+            <a:extLst>
+              <a:ext uri="{FF2B5EF4-FFF2-40B4-BE49-F238E27FC236}">
+                <a16:creationId xmlns:a16="http://schemas.microsoft.com/office/drawing/2014/main" id="{830AAC6C-D474-7144-4A2C-AD2D023425AE}"/>
+              </a:ext>
+            </a:extLst>
+          </p:cNvPr>
+          <p:cNvSpPr/>
+          <p:nvPr/>
+        </p:nvSpPr>
+        <p:spPr>
+          <a:xfrm>
+            <a:off x="-1828800" y="4114800"/>
+            <a:ext cx="5029200" cy="4572000"/>
+          </a:xfrm>
+          <a:prstGeom prst="ellipse">
+            <a:avLst/>
+          </a:prstGeom>
+          <a:solidFill>
+            <a:srgbClr val="0A121E"/>
+          </a:solidFill>
+          <a:ln>
+            <a:noFill/>
+          </a:ln>
+        </p:spPr>
+        <p:style>
+          <a:lnRef idx="1">
+            <a:schemeClr val="accent1"/>
+          </a:lnRef>
+          <a:fillRef idx="3">
+            <a:schemeClr val="accent1"/>
+          </a:fillRef>
+          <a:effectRef idx="2">
+            <a:schemeClr val="accent1"/>
+          </a:effectRef>
+          <a:fontRef idx="minor">
+            <a:schemeClr val="lt1"/>
+          </a:fontRef>
+        </p:style>
+        <p:txBody>
+          <a:bodyPr rtlCol="0" anchor="ctr"/>
+          <a:lstStyle/>
+          <a:p>
+            <a:pPr algn="ctr"/>
+            <a:endParaRPr/>
+          </a:p>
+        </p:txBody>
+      </p:sp>
+      <p:sp>
+        <p:nvSpPr>
           <p:cNvPr id="2" name="TextBox 1"/>
           <p:cNvSpPr txBox="1"/>
           <p:nvPr/>
@@ -4588,6 +4790,58 @@
       </p:grpSpPr>
       <p:sp>
         <p:nvSpPr>
+          <p:cNvPr id="31" name="Oval 2">
+            <a:extLst>
+              <a:ext uri="{FF2B5EF4-FFF2-40B4-BE49-F238E27FC236}">
+                <a16:creationId xmlns:a16="http://schemas.microsoft.com/office/drawing/2014/main" id="{B0DF1433-223E-5605-7A86-4D942F2129F3}"/>
+              </a:ext>
+            </a:extLst>
+          </p:cNvPr>
+          <p:cNvSpPr/>
+          <p:nvPr/>
+        </p:nvSpPr>
+        <p:spPr>
+          <a:xfrm>
+            <a:off x="8153400" y="-1879092"/>
+            <a:ext cx="5943600" cy="5486400"/>
+          </a:xfrm>
+          <a:prstGeom prst="ellipse">
+            <a:avLst/>
+          </a:prstGeom>
+          <a:solidFill>
+            <a:srgbClr val="0070C0">
+              <a:alpha val="69804"/>
+            </a:srgbClr>
+          </a:solidFill>
+          <a:ln>
+            <a:noFill/>
+          </a:ln>
+        </p:spPr>
+        <p:style>
+          <a:lnRef idx="1">
+            <a:schemeClr val="accent1"/>
+          </a:lnRef>
+          <a:fillRef idx="3">
+            <a:schemeClr val="accent1"/>
+          </a:fillRef>
+          <a:effectRef idx="2">
+            <a:schemeClr val="accent1"/>
+          </a:effectRef>
+          <a:fontRef idx="minor">
+            <a:schemeClr val="lt1"/>
+          </a:fontRef>
+        </p:style>
+        <p:txBody>
+          <a:bodyPr rtlCol="0" anchor="ctr"/>
+          <a:lstStyle/>
+          <a:p>
+            <a:pPr algn="ctr"/>
+            <a:endParaRPr dirty="0"/>
+          </a:p>
+        </p:txBody>
+      </p:sp>
+      <p:sp>
+        <p:nvSpPr>
           <p:cNvPr id="2" name="TextBox 1"/>
           <p:cNvSpPr txBox="1"/>
           <p:nvPr/>
@@ -5784,6 +6038,58 @@
           <a:chExt cx="0" cy="0"/>
         </a:xfrm>
       </p:grpSpPr>
+      <p:sp>
+        <p:nvSpPr>
+          <p:cNvPr id="32" name="Oval 2">
+            <a:extLst>
+              <a:ext uri="{FF2B5EF4-FFF2-40B4-BE49-F238E27FC236}">
+                <a16:creationId xmlns:a16="http://schemas.microsoft.com/office/drawing/2014/main" id="{339B8C06-2C93-E1CB-7435-0B467610DDCE}"/>
+              </a:ext>
+            </a:extLst>
+          </p:cNvPr>
+          <p:cNvSpPr/>
+          <p:nvPr/>
+        </p:nvSpPr>
+        <p:spPr>
+          <a:xfrm>
+            <a:off x="8153400" y="-1879092"/>
+            <a:ext cx="5943600" cy="5486400"/>
+          </a:xfrm>
+          <a:prstGeom prst="ellipse">
+            <a:avLst/>
+          </a:prstGeom>
+          <a:solidFill>
+            <a:srgbClr val="00823B">
+              <a:alpha val="69804"/>
+            </a:srgbClr>
+          </a:solidFill>
+          <a:ln>
+            <a:noFill/>
+          </a:ln>
+        </p:spPr>
+        <p:style>
+          <a:lnRef idx="1">
+            <a:schemeClr val="accent1"/>
+          </a:lnRef>
+          <a:fillRef idx="3">
+            <a:schemeClr val="accent1"/>
+          </a:fillRef>
+          <a:effectRef idx="2">
+            <a:schemeClr val="accent1"/>
+          </a:effectRef>
+          <a:fontRef idx="minor">
+            <a:schemeClr val="lt1"/>
+          </a:fontRef>
+        </p:style>
+        <p:txBody>
+          <a:bodyPr rtlCol="0" anchor="ctr"/>
+          <a:lstStyle/>
+          <a:p>
+            <a:pPr algn="ctr"/>
+            <a:endParaRPr dirty="0"/>
+          </a:p>
+        </p:txBody>
+      </p:sp>
       <p:sp>
         <p:nvSpPr>
           <p:cNvPr id="2" name="TextBox 1"/>

</xml_diff>